<commit_message>
Merge with master and additional references
</commit_message>
<xml_diff>
--- a/figures/resources/optical_sectioning.pptx
+++ b/figures/resources/optical_sectioning.pptx
@@ -245,7 +245,7 @@
           <a:p>
             <a:fld id="{B09E179D-AE25-442C-9DBD-25AA24DE7ADF}" type="datetimeFigureOut">
               <a:rPr lang="en-US" smtClean="0"/>
-              <a:t>4/24/26</a:t>
+              <a:t>5/31/26</a:t>
             </a:fld>
             <a:endParaRPr lang="en-US"/>
           </a:p>
@@ -415,7 +415,7 @@
           <a:p>
             <a:fld id="{B09E179D-AE25-442C-9DBD-25AA24DE7ADF}" type="datetimeFigureOut">
               <a:rPr lang="en-US" smtClean="0"/>
-              <a:t>4/24/26</a:t>
+              <a:t>5/31/26</a:t>
             </a:fld>
             <a:endParaRPr lang="en-US"/>
           </a:p>
@@ -595,7 +595,7 @@
           <a:p>
             <a:fld id="{B09E179D-AE25-442C-9DBD-25AA24DE7ADF}" type="datetimeFigureOut">
               <a:rPr lang="en-US" smtClean="0"/>
-              <a:t>4/24/26</a:t>
+              <a:t>5/31/26</a:t>
             </a:fld>
             <a:endParaRPr lang="en-US"/>
           </a:p>
@@ -765,7 +765,7 @@
           <a:p>
             <a:fld id="{B09E179D-AE25-442C-9DBD-25AA24DE7ADF}" type="datetimeFigureOut">
               <a:rPr lang="en-US" smtClean="0"/>
-              <a:t>4/24/26</a:t>
+              <a:t>5/31/26</a:t>
             </a:fld>
             <a:endParaRPr lang="en-US"/>
           </a:p>
@@ -1011,7 +1011,7 @@
           <a:p>
             <a:fld id="{B09E179D-AE25-442C-9DBD-25AA24DE7ADF}" type="datetimeFigureOut">
               <a:rPr lang="en-US" smtClean="0"/>
-              <a:t>4/24/26</a:t>
+              <a:t>5/31/26</a:t>
             </a:fld>
             <a:endParaRPr lang="en-US"/>
           </a:p>
@@ -1243,7 +1243,7 @@
           <a:p>
             <a:fld id="{B09E179D-AE25-442C-9DBD-25AA24DE7ADF}" type="datetimeFigureOut">
               <a:rPr lang="en-US" smtClean="0"/>
-              <a:t>4/24/26</a:t>
+              <a:t>5/31/26</a:t>
             </a:fld>
             <a:endParaRPr lang="en-US"/>
           </a:p>
@@ -1610,7 +1610,7 @@
           <a:p>
             <a:fld id="{B09E179D-AE25-442C-9DBD-25AA24DE7ADF}" type="datetimeFigureOut">
               <a:rPr lang="en-US" smtClean="0"/>
-              <a:t>4/24/26</a:t>
+              <a:t>5/31/26</a:t>
             </a:fld>
             <a:endParaRPr lang="en-US"/>
           </a:p>
@@ -1728,7 +1728,7 @@
           <a:p>
             <a:fld id="{B09E179D-AE25-442C-9DBD-25AA24DE7ADF}" type="datetimeFigureOut">
               <a:rPr lang="en-US" smtClean="0"/>
-              <a:t>4/24/26</a:t>
+              <a:t>5/31/26</a:t>
             </a:fld>
             <a:endParaRPr lang="en-US"/>
           </a:p>
@@ -1823,7 +1823,7 @@
           <a:p>
             <a:fld id="{B09E179D-AE25-442C-9DBD-25AA24DE7ADF}" type="datetimeFigureOut">
               <a:rPr lang="en-US" smtClean="0"/>
-              <a:t>4/24/26</a:t>
+              <a:t>5/31/26</a:t>
             </a:fld>
             <a:endParaRPr lang="en-US"/>
           </a:p>
@@ -2100,7 +2100,7 @@
           <a:p>
             <a:fld id="{B09E179D-AE25-442C-9DBD-25AA24DE7ADF}" type="datetimeFigureOut">
               <a:rPr lang="en-US" smtClean="0"/>
-              <a:t>4/24/26</a:t>
+              <a:t>5/31/26</a:t>
             </a:fld>
             <a:endParaRPr lang="en-US"/>
           </a:p>
@@ -2357,7 +2357,7 @@
           <a:p>
             <a:fld id="{B09E179D-AE25-442C-9DBD-25AA24DE7ADF}" type="datetimeFigureOut">
               <a:rPr lang="en-US" smtClean="0"/>
-              <a:t>4/24/26</a:t>
+              <a:t>5/31/26</a:t>
             </a:fld>
             <a:endParaRPr lang="en-US"/>
           </a:p>
@@ -2570,7 +2570,7 @@
           <a:p>
             <a:fld id="{B09E179D-AE25-442C-9DBD-25AA24DE7ADF}" type="datetimeFigureOut">
               <a:rPr lang="en-US" smtClean="0"/>
-              <a:t>4/24/26</a:t>
+              <a:t>5/31/26</a:t>
             </a:fld>
             <a:endParaRPr lang="en-US"/>
           </a:p>
@@ -4933,15 +4933,15 @@
               </a:ext>
             </a:extLst>
           </a:blip>
-          <a:srcRect t="10862"/>
+          <a:srcRect l="29793" t="10862"/>
           <a:stretch>
             <a:fillRect/>
           </a:stretch>
         </p:blipFill>
         <p:spPr>
           <a:xfrm>
-            <a:off x="801398" y="563568"/>
-            <a:ext cx="11029625" cy="5362655"/>
+            <a:off x="2319867" y="800308"/>
+            <a:ext cx="7743480" cy="5362655"/>
           </a:xfrm>
           <a:prstGeom prst="rect">
             <a:avLst/>

</xml_diff>